<commit_message>
fix(deck): audit fixes - sourced stats only, chip order, spacing
Full deck audit (visual 11/11 CLEAN, live claims verified, repo-traced):
- slide 10: drop unsourced '10 million+' estimate -> qualitative
  'Millions'; footnote now cites only the sourced 10.3% Findex figure
- renumber section chips to actual presentation order
  (01 problem, 02 live demo, 03 how it works, 04 trust, 05 why)
- slide 8: remove double space before the Urdu amount run
- README: deck outline corrected (no traction/ask slides exist)
</commit_message>
<xml_diff>
--- a/docs/Bizro_Pitch.pptx
+++ b/docs/Bizro_Pitch.pptx
@@ -582,7 +582,7 @@
           <a:lstStyle/>
           <a:p>
             <a:r>
-              <a:t>The impact: months of voice notes he was already sending become a credit history a lender can read — for the ten million plus unbanked micro-entrepreneurs of Pakistan. No behavior change is required; the voice note and the receipt photo already exist. Bizro simply makes them legible to the rail that was built for him.</a:t>
+              <a:t>The impact: months of voice notes he was already sending become a credit history a lender can read — for the millions of unbanked micro-entrepreneurs of Pakistan. No behavior change is required; the voice note and the receipt photo already exist. Bizro simply makes them legible to the rail that was built for him.</a:t>
             </a:r>
           </a:p>
         </p:txBody>
@@ -5090,7 +5090,7 @@
                 </a:solidFill>
                 <a:latin typeface="Arial Black"/>
               </a:rPr>
-              <a:t>10 million+</a:t>
+              <a:t>Millions</a:t>
             </a:r>
             <a:r>
               <a:rPr sz="2400" b="0">
@@ -5099,7 +5099,7 @@
                 </a:solidFill>
                 <a:latin typeface="Arial"/>
               </a:rPr>
-              <a:t> unbanked micro-entrepreneurs of Pakistan.</a:t>
+              <a:t> of unbanked micro-entrepreneurs in Pakistan.</a:t>
             </a:r>
           </a:p>
         </p:txBody>
@@ -5138,7 +5138,7 @@
                 </a:solidFill>
                 <a:latin typeface="Arial"/>
               </a:rPr>
-              <a:t>Scale estimate: informal micro-enterprises vs the 10.3% formal-account share (World Bank Global Findex).</a:t>
+              <a:t>Scale context: only 10.3% of Pakistani adults hold a formal account (World Bank Global Findex).</a:t>
             </a:r>
           </a:p>
         </p:txBody>
@@ -9548,7 +9548,7 @@
                 </a:solidFill>
                 <a:latin typeface="Arial"/>
               </a:rPr>
-              <a:t>05 · Live demo</a:t>
+              <a:t>02 · Live demo</a:t>
             </a:r>
           </a:p>
         </p:txBody>
@@ -10248,7 +10248,7 @@
                 </a:solidFill>
                 <a:latin typeface="Arial"/>
               </a:rPr>
-              <a:t>02 · How it works</a:t>
+              <a:t>03 · How it works</a:t>
             </a:r>
           </a:p>
         </p:txBody>
@@ -13284,7 +13284,7 @@
                 </a:solidFill>
                 <a:latin typeface="Arial Black"/>
               </a:rPr>
-              <a:t>PKR 5,000  </a:t>
+              <a:t>PKR 5,000 </a:t>
             </a:r>
             <a:r>
               <a:rPr sz="1600" b="0">
@@ -13794,7 +13794,7 @@
                 </a:solidFill>
                 <a:latin typeface="Arial"/>
               </a:rPr>
-              <a:t>03 · Why Bizro</a:t>
+              <a:t>05 · Why Bizro</a:t>
             </a:r>
           </a:p>
         </p:txBody>

</xml_diff>